<commit_message>
slides: add 'What it runs on' tech-stack slide (icon badges; clarifies Python+Postgres, Node is build-only)
</commit_message>
<xml_diff>
--- a/slides/Case-Tracker-Overview.pptx
+++ b/slides/Case-Tracker-Overview.pptx
@@ -21,9 +21,10 @@
     <p:sldId id="269" r:id="rId15"/>
     <p:sldId id="270" r:id="rId16"/>
     <p:sldId id="271" r:id="rId17"/>
+    <p:sldId id="272" r:id="rId18"/>
   </p:sldIdLst>
   <p:notesMasterIdLst>
-    <p:notesMasterId r:id="rId18"/>
+    <p:notesMasterId r:id="rId19"/>
   </p:notesMasterIdLst>
   <p:sldSz cx="12192000" cy="6858000"/>
   <p:notesSz cx="6858000" cy="12192000"/>
@@ -1157,6 +1158,94 @@
             <a:fld id="{F7021451-1387-4CA6-816F-3879F97B5CBC}" type="slidenum">
               <a:rPr lang="en-US"/>
               <a:t>16</a:t>
+            </a:fld>
+            <a:endParaRPr lang="en-US"/>
+          </a:p>
+        </p:txBody>
+      </p:sp>
+    </p:spTree>
+    <p:extLst>
+      <p:ext uri="{BB962C8B-B14F-4D97-AF65-F5344CB8AC3E}">
+        <p14:creationId xmlns:p14="http://schemas.microsoft.com/office/powerpoint/2010/main" val="1024086991"/>
+      </p:ext>
+    </p:extLst>
+  </p:cSld>
+  <p:clrMapOvr>
+    <a:masterClrMapping/>
+  </p:clrMapOvr>
+</p:notes>
+</file>
+
+<file path=ppt/notesSlides/notesSlide17.xml><?xml version="1.0" encoding="utf-8"?>
+<p:notes xmlns:a="http://schemas.openxmlformats.org/drawingml/2006/main" xmlns:r="http://schemas.openxmlformats.org/officeDocument/2006/relationships" xmlns:p="http://schemas.openxmlformats.org/presentationml/2006/main">
+  <p:cSld>
+    <p:spTree>
+      <p:nvGrpSpPr>
+        <p:cNvPr id="1" name=""/>
+        <p:cNvGrpSpPr/>
+        <p:nvPr/>
+      </p:nvGrpSpPr>
+      <p:grpSpPr>
+        <a:xfrm>
+          <a:off x="0" y="0"/>
+          <a:ext cx="0" cy="0"/>
+          <a:chOff x="0" y="0"/>
+          <a:chExt cx="0" cy="0"/>
+        </a:xfrm>
+      </p:grpSpPr>
+      <p:sp>
+        <p:nvSpPr>
+          <p:cNvPr id="2" name="Slide Image Placeholder 1"/>
+          <p:cNvSpPr>
+            <a:spLocks noGrp="1" noRot="1" noChangeAspect="1"/>
+          </p:cNvSpPr>
+          <p:nvPr>
+            <p:ph type="sldImg"/>
+          </p:nvPr>
+        </p:nvSpPr>
+        <p:spPr/>
+      </p:sp>
+      <p:sp>
+        <p:nvSpPr>
+          <p:cNvPr id="3" name="Notes Placeholder 2"/>
+          <p:cNvSpPr>
+            <a:spLocks noGrp="1"/>
+          </p:cNvSpPr>
+          <p:nvPr>
+            <p:ph type="body" idx="1"/>
+          </p:nvPr>
+        </p:nvSpPr>
+        <p:spPr/>
+        <p:txBody>
+          <a:bodyPr/>
+          <a:lstStyle/>
+          <a:p>
+            <a:r>
+              <a:rPr lang="en-US" dirty="0"/>
+              <a:t/>
+            </a:r>
+            <a:endParaRPr lang="en-US" dirty="0"/>
+          </a:p>
+        </p:txBody>
+      </p:sp>
+      <p:sp>
+        <p:nvSpPr>
+          <p:cNvPr id="4" name="Slide Number Placeholder 3"/>
+          <p:cNvSpPr>
+            <a:spLocks noGrp="1"/>
+          </p:cNvSpPr>
+          <p:nvPr>
+            <p:ph type="sldNum" sz="quarter" idx="10"/>
+          </p:nvPr>
+        </p:nvSpPr>
+        <p:spPr/>
+        <p:txBody>
+          <a:bodyPr/>
+          <a:lstStyle/>
+          <a:p>
+            <a:fld id="{F7021451-1387-4CA6-816F-3879F97B5CBC}" type="slidenum">
+              <a:rPr lang="en-US"/>
+              <a:t>17</a:t>
             </a:fld>
             <a:endParaRPr lang="en-US"/>
           </a:p>
@@ -5166,6 +5255,841 @@
         </p:nvSpPr>
         <p:spPr>
           <a:xfrm>
+            <a:off x="548640" y="6419088"/>
+            <a:ext cx="11091672" cy="0"/>
+          </a:xfrm>
+          <a:prstGeom prst="line">
+            <a:avLst/>
+          </a:prstGeom>
+          <a:noFill/>
+          <a:ln w="12700">
+            <a:solidFill>
+              <a:srgbClr val="E5E7EB"/>
+            </a:solidFill>
+            <a:prstDash val="solid"/>
+          </a:ln>
+        </p:spPr>
+      </p:sp>
+      <p:sp>
+        <p:nvSpPr>
+          <p:cNvPr id="3" name="Text 1"/>
+          <p:cNvSpPr/>
+          <p:nvPr/>
+        </p:nvSpPr>
+        <p:spPr>
+          <a:xfrm>
+            <a:off x="548640" y="6437376"/>
+            <a:ext cx="9144000" cy="292608"/>
+          </a:xfrm>
+          <a:prstGeom prst="rect">
+            <a:avLst/>
+          </a:prstGeom>
+          <a:noFill/>
+          <a:ln/>
+        </p:spPr>
+        <p:txBody>
+          <a:bodyPr wrap="square" rtlCol="0" anchor="ctr"/>
+          <a:lstStyle/>
+          <a:p>
+            <a:pPr algn="l" indent="0" marL="0">
+              <a:buNone/>
+            </a:pPr>
+            <a:r>
+              <a:rPr lang="en-US" sz="900" dirty="0">
+                <a:solidFill>
+                  <a:srgbClr val="6B7280"/>
+                </a:solidFill>
+                <a:latin typeface="Segoe UI" pitchFamily="34" charset="0"/>
+                <a:ea typeface="Segoe UI" pitchFamily="34" charset="-122"/>
+                <a:cs typeface="Segoe UI" pitchFamily="34" charset="-120"/>
+              </a:rPr>
+              <a:t>Case Tracker  ·  https://hltsai9.github.io/threenine/</a:t>
+            </a:r>
+            <a:endParaRPr lang="en-US" sz="900" dirty="0"/>
+          </a:p>
+        </p:txBody>
+      </p:sp>
+      <p:sp>
+        <p:nvSpPr>
+          <p:cNvPr id="4" name="Text 2"/>
+          <p:cNvSpPr/>
+          <p:nvPr/>
+        </p:nvSpPr>
+        <p:spPr>
+          <a:xfrm>
+            <a:off x="10972800" y="6437376"/>
+            <a:ext cx="640080" cy="292608"/>
+          </a:xfrm>
+          <a:prstGeom prst="rect">
+            <a:avLst/>
+          </a:prstGeom>
+          <a:noFill/>
+          <a:ln/>
+        </p:spPr>
+        <p:txBody>
+          <a:bodyPr wrap="square" rtlCol="0" anchor="ctr"/>
+          <a:lstStyle/>
+          <a:p>
+            <a:pPr algn="r" indent="0" marL="0">
+              <a:buNone/>
+            </a:pPr>
+            <a:r>
+              <a:rPr lang="en-US" sz="900" dirty="0">
+                <a:solidFill>
+                  <a:srgbClr val="6B7280"/>
+                </a:solidFill>
+                <a:latin typeface="Segoe UI" pitchFamily="34" charset="0"/>
+                <a:ea typeface="Segoe UI" pitchFamily="34" charset="-122"/>
+                <a:cs typeface="Segoe UI" pitchFamily="34" charset="-120"/>
+              </a:rPr>
+              <a:t>15</a:t>
+            </a:r>
+            <a:endParaRPr lang="en-US" sz="900" dirty="0"/>
+          </a:p>
+        </p:txBody>
+      </p:sp>
+      <p:sp>
+        <p:nvSpPr>
+          <p:cNvPr id="5" name="Text 3"/>
+          <p:cNvSpPr/>
+          <p:nvPr/>
+        </p:nvSpPr>
+        <p:spPr>
+          <a:xfrm>
+            <a:off x="548640" y="411480"/>
+            <a:ext cx="11064240" cy="640080"/>
+          </a:xfrm>
+          <a:prstGeom prst="rect">
+            <a:avLst/>
+          </a:prstGeom>
+          <a:noFill/>
+          <a:ln/>
+        </p:spPr>
+        <p:txBody>
+          <a:bodyPr wrap="square" rtlCol="0" anchor="ctr"/>
+          <a:lstStyle/>
+          <a:p>
+            <a:pPr indent="0" marL="0">
+              <a:buNone/>
+            </a:pPr>
+            <a:r>
+              <a:rPr lang="en-US" sz="2600" b="1" dirty="0">
+                <a:solidFill>
+                  <a:srgbClr val="1F2937"/>
+                </a:solidFill>
+                <a:latin typeface="Segoe UI" pitchFamily="34" charset="0"/>
+                <a:ea typeface="Segoe UI" pitchFamily="34" charset="-122"/>
+                <a:cs typeface="Segoe UI" pitchFamily="34" charset="-120"/>
+              </a:rPr>
+              <a:t>What it runs on</a:t>
+            </a:r>
+            <a:endParaRPr lang="en-US" sz="2600" dirty="0"/>
+          </a:p>
+        </p:txBody>
+      </p:sp>
+      <p:sp>
+        <p:nvSpPr>
+          <p:cNvPr id="6" name="Shape 4"/>
+          <p:cNvSpPr/>
+          <p:nvPr/>
+        </p:nvSpPr>
+        <p:spPr>
+          <a:xfrm>
+            <a:off x="566928" y="1078992"/>
+            <a:ext cx="1280160" cy="54864"/>
+          </a:xfrm>
+          <a:prstGeom prst="rect">
+            <a:avLst/>
+          </a:prstGeom>
+          <a:solidFill>
+            <a:srgbClr val="2563EB"/>
+          </a:solidFill>
+          <a:ln/>
+        </p:spPr>
+      </p:sp>
+      <p:sp>
+        <p:nvSpPr>
+          <p:cNvPr id="7" name="Text 5"/>
+          <p:cNvSpPr/>
+          <p:nvPr/>
+        </p:nvSpPr>
+        <p:spPr>
+          <a:xfrm>
+            <a:off x="548640" y="1152144"/>
+            <a:ext cx="11064240" cy="365760"/>
+          </a:xfrm>
+          <a:prstGeom prst="rect">
+            <a:avLst/>
+          </a:prstGeom>
+          <a:noFill/>
+          <a:ln/>
+        </p:spPr>
+        <p:txBody>
+          <a:bodyPr wrap="square" rtlCol="0" anchor="ctr"/>
+          <a:lstStyle/>
+          <a:p>
+            <a:pPr indent="0" marL="0">
+              <a:buNone/>
+            </a:pPr>
+            <a:r>
+              <a:rPr lang="en-US" sz="1300" dirty="0">
+                <a:solidFill>
+                  <a:srgbClr val="6B7280"/>
+                </a:solidFill>
+                <a:latin typeface="Segoe UI" pitchFamily="34" charset="0"/>
+                <a:ea typeface="Segoe UI" pitchFamily="34" charset="-122"/>
+                <a:cs typeface="Segoe UI" pitchFamily="34" charset="-120"/>
+              </a:rPr>
+              <a:t>A Python web service + PostgreSQL. Node is build-time only — never needed to run the site.</a:t>
+            </a:r>
+            <a:endParaRPr lang="en-US" sz="1300" dirty="0"/>
+          </a:p>
+        </p:txBody>
+      </p:sp>
+      <p:sp>
+        <p:nvSpPr>
+          <p:cNvPr id="8" name="Shape 6"/>
+          <p:cNvSpPr/>
+          <p:nvPr/>
+        </p:nvSpPr>
+        <p:spPr>
+          <a:xfrm>
+            <a:off x="822960" y="1783080"/>
+            <a:ext cx="658368" cy="658368"/>
+          </a:xfrm>
+          <a:prstGeom prst="ellipse">
+            <a:avLst/>
+          </a:prstGeom>
+          <a:solidFill>
+            <a:srgbClr val="EEF2FF"/>
+          </a:solidFill>
+          <a:ln w="12700">
+            <a:solidFill>
+              <a:srgbClr val="E5E7EB"/>
+            </a:solidFill>
+            <a:prstDash val="solid"/>
+          </a:ln>
+        </p:spPr>
+      </p:sp>
+      <p:sp>
+        <p:nvSpPr>
+          <p:cNvPr id="9" name="Text 7"/>
+          <p:cNvSpPr/>
+          <p:nvPr/>
+        </p:nvSpPr>
+        <p:spPr>
+          <a:xfrm>
+            <a:off x="822960" y="1783080"/>
+            <a:ext cx="658368" cy="658368"/>
+          </a:xfrm>
+          <a:prstGeom prst="rect">
+            <a:avLst/>
+          </a:prstGeom>
+          <a:noFill/>
+          <a:ln/>
+        </p:spPr>
+        <p:txBody>
+          <a:bodyPr wrap="square" rtlCol="0" anchor="ctr"/>
+          <a:lstStyle/>
+          <a:p>
+            <a:pPr algn="ctr" indent="0" marL="0">
+              <a:buNone/>
+            </a:pPr>
+            <a:r>
+              <a:rPr lang="en-US" sz="2600" dirty="0">
+                <a:solidFill>
+                  <a:srgbClr val="000000"/>
+                </a:solidFill>
+                <a:latin typeface="Segoe UI" pitchFamily="34" charset="0"/>
+                <a:ea typeface="Segoe UI" pitchFamily="34" charset="-122"/>
+                <a:cs typeface="Segoe UI" pitchFamily="34" charset="-120"/>
+              </a:rPr>
+              <a:t>🌐</a:t>
+            </a:r>
+            <a:endParaRPr lang="en-US" sz="2600" dirty="0"/>
+          </a:p>
+        </p:txBody>
+      </p:sp>
+      <p:sp>
+        <p:nvSpPr>
+          <p:cNvPr id="10" name="Text 8"/>
+          <p:cNvSpPr/>
+          <p:nvPr/>
+        </p:nvSpPr>
+        <p:spPr>
+          <a:xfrm>
+            <a:off x="1783080" y="1728216"/>
+            <a:ext cx="9601200" cy="768096"/>
+          </a:xfrm>
+          <a:prstGeom prst="rect">
+            <a:avLst/>
+          </a:prstGeom>
+          <a:noFill/>
+          <a:ln/>
+        </p:spPr>
+        <p:txBody>
+          <a:bodyPr wrap="square" rtlCol="0" anchor="ctr"/>
+          <a:lstStyle/>
+          <a:p>
+            <a:pPr indent="0" marL="0">
+              <a:lnSpc>
+                <a:spcPct val="105000"/>
+              </a:lnSpc>
+              <a:buNone/>
+            </a:pPr>
+            <a:r>
+              <a:rPr lang="en-US" sz="1700" b="1" dirty="0">
+                <a:solidFill>
+                  <a:srgbClr val="1F2937"/>
+                </a:solidFill>
+                <a:latin typeface="Segoe UI" pitchFamily="34" charset="0"/>
+                <a:ea typeface="Segoe UI" pitchFamily="34" charset="-122"/>
+                <a:cs typeface="Segoe UI" pitchFamily="34" charset="-120"/>
+              </a:rPr>
+              <a:t>Front end — the web app
+</a:t>
+            </a:r>
+            <a:pPr indent="0" marL="0">
+              <a:lnSpc>
+                <a:spcPct val="105000"/>
+              </a:lnSpc>
+              <a:buNone/>
+            </a:pPr>
+            <a:r>
+              <a:rPr lang="en-US" sz="1400" dirty="0">
+                <a:solidFill>
+                  <a:srgbClr val="6B7280"/>
+                </a:solidFill>
+                <a:latin typeface="Segoe UI" pitchFamily="34" charset="0"/>
+                <a:ea typeface="Segoe UI" pitchFamily="34" charset="-122"/>
+                <a:cs typeface="Segoe UI" pitchFamily="34" charset="-120"/>
+              </a:rPr>
+              <a:t>Plain HTML / CSS / vanilla JavaScript. No framework, no Node in the browser; just static files.</a:t>
+            </a:r>
+            <a:endParaRPr lang="en-US" sz="1700" dirty="0"/>
+          </a:p>
+        </p:txBody>
+      </p:sp>
+      <p:sp>
+        <p:nvSpPr>
+          <p:cNvPr id="11" name="Shape 9"/>
+          <p:cNvSpPr/>
+          <p:nvPr/>
+        </p:nvSpPr>
+        <p:spPr>
+          <a:xfrm>
+            <a:off x="822960" y="2697480"/>
+            <a:ext cx="658368" cy="658368"/>
+          </a:xfrm>
+          <a:prstGeom prst="ellipse">
+            <a:avLst/>
+          </a:prstGeom>
+          <a:solidFill>
+            <a:srgbClr val="E8F2EC"/>
+          </a:solidFill>
+          <a:ln w="12700">
+            <a:solidFill>
+              <a:srgbClr val="E5E7EB"/>
+            </a:solidFill>
+            <a:prstDash val="solid"/>
+          </a:ln>
+        </p:spPr>
+      </p:sp>
+      <p:sp>
+        <p:nvSpPr>
+          <p:cNvPr id="12" name="Text 10"/>
+          <p:cNvSpPr/>
+          <p:nvPr/>
+        </p:nvSpPr>
+        <p:spPr>
+          <a:xfrm>
+            <a:off x="822960" y="2697480"/>
+            <a:ext cx="658368" cy="658368"/>
+          </a:xfrm>
+          <a:prstGeom prst="rect">
+            <a:avLst/>
+          </a:prstGeom>
+          <a:noFill/>
+          <a:ln/>
+        </p:spPr>
+        <p:txBody>
+          <a:bodyPr wrap="square" rtlCol="0" anchor="ctr"/>
+          <a:lstStyle/>
+          <a:p>
+            <a:pPr algn="ctr" indent="0" marL="0">
+              <a:buNone/>
+            </a:pPr>
+            <a:r>
+              <a:rPr lang="en-US" sz="2600" dirty="0">
+                <a:solidFill>
+                  <a:srgbClr val="000000"/>
+                </a:solidFill>
+                <a:latin typeface="Segoe UI" pitchFamily="34" charset="0"/>
+                <a:ea typeface="Segoe UI" pitchFamily="34" charset="-122"/>
+                <a:cs typeface="Segoe UI" pitchFamily="34" charset="-120"/>
+              </a:rPr>
+              <a:t>🐍</a:t>
+            </a:r>
+            <a:endParaRPr lang="en-US" sz="2600" dirty="0"/>
+          </a:p>
+        </p:txBody>
+      </p:sp>
+      <p:sp>
+        <p:nvSpPr>
+          <p:cNvPr id="13" name="Text 11"/>
+          <p:cNvSpPr/>
+          <p:nvPr/>
+        </p:nvSpPr>
+        <p:spPr>
+          <a:xfrm>
+            <a:off x="1783080" y="2642616"/>
+            <a:ext cx="9601200" cy="768096"/>
+          </a:xfrm>
+          <a:prstGeom prst="rect">
+            <a:avLst/>
+          </a:prstGeom>
+          <a:noFill/>
+          <a:ln/>
+        </p:spPr>
+        <p:txBody>
+          <a:bodyPr wrap="square" rtlCol="0" anchor="ctr"/>
+          <a:lstStyle/>
+          <a:p>
+            <a:pPr indent="0" marL="0">
+              <a:lnSpc>
+                <a:spcPct val="105000"/>
+              </a:lnSpc>
+              <a:buNone/>
+            </a:pPr>
+            <a:r>
+              <a:rPr lang="en-US" sz="1700" b="1" dirty="0">
+                <a:solidFill>
+                  <a:srgbClr val="1F2937"/>
+                </a:solidFill>
+                <a:latin typeface="Segoe UI" pitchFamily="34" charset="0"/>
+                <a:ea typeface="Segoe UI" pitchFamily="34" charset="-122"/>
+                <a:cs typeface="Segoe UI" pitchFamily="34" charset="-120"/>
+              </a:rPr>
+              <a:t>Back end — web server + API
+</a:t>
+            </a:r>
+            <a:pPr indent="0" marL="0">
+              <a:lnSpc>
+                <a:spcPct val="105000"/>
+              </a:lnSpc>
+              <a:buNone/>
+            </a:pPr>
+            <a:r>
+              <a:rPr lang="en-US" sz="1400" dirty="0">
+                <a:solidFill>
+                  <a:srgbClr val="6B7280"/>
+                </a:solidFill>
+                <a:latin typeface="Segoe UI" pitchFamily="34" charset="0"/>
+                <a:ea typeface="Segoe UI" pitchFamily="34" charset="-122"/>
+                <a:cs typeface="Segoe UI" pitchFamily="34" charset="-120"/>
+              </a:rPr>
+              <a:t>Python · FastAPI · uvicorn. Serves the app and the /api endpoints from one origin.</a:t>
+            </a:r>
+            <a:endParaRPr lang="en-US" sz="1700" dirty="0"/>
+          </a:p>
+        </p:txBody>
+      </p:sp>
+      <p:sp>
+        <p:nvSpPr>
+          <p:cNvPr id="14" name="Shape 12"/>
+          <p:cNvSpPr/>
+          <p:nvPr/>
+        </p:nvSpPr>
+        <p:spPr>
+          <a:xfrm>
+            <a:off x="822960" y="3611880"/>
+            <a:ext cx="658368" cy="658368"/>
+          </a:xfrm>
+          <a:prstGeom prst="ellipse">
+            <a:avLst/>
+          </a:prstGeom>
+          <a:solidFill>
+            <a:srgbClr val="EFF6FF"/>
+          </a:solidFill>
+          <a:ln w="12700">
+            <a:solidFill>
+              <a:srgbClr val="E5E7EB"/>
+            </a:solidFill>
+            <a:prstDash val="solid"/>
+          </a:ln>
+        </p:spPr>
+      </p:sp>
+      <p:sp>
+        <p:nvSpPr>
+          <p:cNvPr id="15" name="Text 13"/>
+          <p:cNvSpPr/>
+          <p:nvPr/>
+        </p:nvSpPr>
+        <p:spPr>
+          <a:xfrm>
+            <a:off x="822960" y="3611880"/>
+            <a:ext cx="658368" cy="658368"/>
+          </a:xfrm>
+          <a:prstGeom prst="rect">
+            <a:avLst/>
+          </a:prstGeom>
+          <a:noFill/>
+          <a:ln/>
+        </p:spPr>
+        <p:txBody>
+          <a:bodyPr wrap="square" rtlCol="0" anchor="ctr"/>
+          <a:lstStyle/>
+          <a:p>
+            <a:pPr algn="ctr" indent="0" marL="0">
+              <a:buNone/>
+            </a:pPr>
+            <a:r>
+              <a:rPr lang="en-US" sz="2600" dirty="0">
+                <a:solidFill>
+                  <a:srgbClr val="000000"/>
+                </a:solidFill>
+                <a:latin typeface="Segoe UI" pitchFamily="34" charset="0"/>
+                <a:ea typeface="Segoe UI" pitchFamily="34" charset="-122"/>
+                <a:cs typeface="Segoe UI" pitchFamily="34" charset="-120"/>
+              </a:rPr>
+              <a:t>🐘</a:t>
+            </a:r>
+            <a:endParaRPr lang="en-US" sz="2600" dirty="0"/>
+          </a:p>
+        </p:txBody>
+      </p:sp>
+      <p:sp>
+        <p:nvSpPr>
+          <p:cNvPr id="16" name="Text 14"/>
+          <p:cNvSpPr/>
+          <p:nvPr/>
+        </p:nvSpPr>
+        <p:spPr>
+          <a:xfrm>
+            <a:off x="1783080" y="3557016"/>
+            <a:ext cx="9601200" cy="768096"/>
+          </a:xfrm>
+          <a:prstGeom prst="rect">
+            <a:avLst/>
+          </a:prstGeom>
+          <a:noFill/>
+          <a:ln/>
+        </p:spPr>
+        <p:txBody>
+          <a:bodyPr wrap="square" rtlCol="0" anchor="ctr"/>
+          <a:lstStyle/>
+          <a:p>
+            <a:pPr indent="0" marL="0">
+              <a:lnSpc>
+                <a:spcPct val="105000"/>
+              </a:lnSpc>
+              <a:buNone/>
+            </a:pPr>
+            <a:r>
+              <a:rPr lang="en-US" sz="1700" b="1" dirty="0">
+                <a:solidFill>
+                  <a:srgbClr val="1F2937"/>
+                </a:solidFill>
+                <a:latin typeface="Segoe UI" pitchFamily="34" charset="0"/>
+                <a:ea typeface="Segoe UI" pitchFamily="34" charset="-122"/>
+                <a:cs typeface="Segoe UI" pitchFamily="34" charset="-120"/>
+              </a:rPr>
+              <a:t>Database
+</a:t>
+            </a:r>
+            <a:pPr indent="0" marL="0">
+              <a:lnSpc>
+                <a:spcPct val="105000"/>
+              </a:lnSpc>
+              <a:buNone/>
+            </a:pPr>
+            <a:r>
+              <a:rPr lang="en-US" sz="1400" dirty="0">
+                <a:solidFill>
+                  <a:srgbClr val="6B7280"/>
+                </a:solidFill>
+                <a:latin typeface="Segoe UI" pitchFamily="34" charset="0"/>
+                <a:ea typeface="Segoe UI" pitchFamily="34" charset="-122"/>
+                <a:cs typeface="Segoe UI" pitchFamily="34" charset="-120"/>
+              </a:rPr>
+              <a:t>PostgreSQL — one shared, live board for every operator and device.</a:t>
+            </a:r>
+            <a:endParaRPr lang="en-US" sz="1700" dirty="0"/>
+          </a:p>
+        </p:txBody>
+      </p:sp>
+      <p:sp>
+        <p:nvSpPr>
+          <p:cNvPr id="17" name="Shape 15"/>
+          <p:cNvSpPr/>
+          <p:nvPr/>
+        </p:nvSpPr>
+        <p:spPr>
+          <a:xfrm>
+            <a:off x="822960" y="4526280"/>
+            <a:ext cx="658368" cy="658368"/>
+          </a:xfrm>
+          <a:prstGeom prst="ellipse">
+            <a:avLst/>
+          </a:prstGeom>
+          <a:solidFill>
+            <a:srgbClr val="FFFBEB"/>
+          </a:solidFill>
+          <a:ln w="12700">
+            <a:solidFill>
+              <a:srgbClr val="E5E7EB"/>
+            </a:solidFill>
+            <a:prstDash val="solid"/>
+          </a:ln>
+        </p:spPr>
+      </p:sp>
+      <p:sp>
+        <p:nvSpPr>
+          <p:cNvPr id="18" name="Text 16"/>
+          <p:cNvSpPr/>
+          <p:nvPr/>
+        </p:nvSpPr>
+        <p:spPr>
+          <a:xfrm>
+            <a:off x="822960" y="4526280"/>
+            <a:ext cx="658368" cy="658368"/>
+          </a:xfrm>
+          <a:prstGeom prst="rect">
+            <a:avLst/>
+          </a:prstGeom>
+          <a:noFill/>
+          <a:ln/>
+        </p:spPr>
+        <p:txBody>
+          <a:bodyPr wrap="square" rtlCol="0" anchor="ctr"/>
+          <a:lstStyle/>
+          <a:p>
+            <a:pPr algn="ctr" indent="0" marL="0">
+              <a:buNone/>
+            </a:pPr>
+            <a:r>
+              <a:rPr lang="en-US" sz="2600" dirty="0">
+                <a:solidFill>
+                  <a:srgbClr val="000000"/>
+                </a:solidFill>
+                <a:latin typeface="Segoe UI" pitchFamily="34" charset="0"/>
+                <a:ea typeface="Segoe UI" pitchFamily="34" charset="-122"/>
+                <a:cs typeface="Segoe UI" pitchFamily="34" charset="-120"/>
+              </a:rPr>
+              <a:t>⏱️</a:t>
+            </a:r>
+            <a:endParaRPr lang="en-US" sz="2600" dirty="0"/>
+          </a:p>
+        </p:txBody>
+      </p:sp>
+      <p:sp>
+        <p:nvSpPr>
+          <p:cNvPr id="19" name="Text 17"/>
+          <p:cNvSpPr/>
+          <p:nvPr/>
+        </p:nvSpPr>
+        <p:spPr>
+          <a:xfrm>
+            <a:off x="1783080" y="4471416"/>
+            <a:ext cx="9601200" cy="768096"/>
+          </a:xfrm>
+          <a:prstGeom prst="rect">
+            <a:avLst/>
+          </a:prstGeom>
+          <a:noFill/>
+          <a:ln/>
+        </p:spPr>
+        <p:txBody>
+          <a:bodyPr wrap="square" rtlCol="0" anchor="ctr"/>
+          <a:lstStyle/>
+          <a:p>
+            <a:pPr indent="0" marL="0">
+              <a:lnSpc>
+                <a:spcPct val="105000"/>
+              </a:lnSpc>
+              <a:buNone/>
+            </a:pPr>
+            <a:r>
+              <a:rPr lang="en-US" sz="1700" b="1" dirty="0">
+                <a:solidFill>
+                  <a:srgbClr val="1F2937"/>
+                </a:solidFill>
+                <a:latin typeface="Segoe UI" pitchFamily="34" charset="0"/>
+                <a:ea typeface="Segoe UI" pitchFamily="34" charset="-122"/>
+                <a:cs typeface="Segoe UI" pitchFamily="34" charset="-120"/>
+              </a:rPr>
+              <a:t>Data sync
+</a:t>
+            </a:r>
+            <a:pPr indent="0" marL="0">
+              <a:lnSpc>
+                <a:spcPct val="105000"/>
+              </a:lnSpc>
+              <a:buNone/>
+            </a:pPr>
+            <a:r>
+              <a:rPr lang="en-US" sz="1400" dirty="0">
+                <a:solidFill>
+                  <a:srgbClr val="6B7280"/>
+                </a:solidFill>
+                <a:latin typeface="Segoe UI" pitchFamily="34" charset="0"/>
+                <a:ea typeface="Segoe UI" pitchFamily="34" charset="-122"/>
+                <a:cs typeface="Segoe UI" pitchFamily="34" charset="-120"/>
+              </a:rPr>
+              <a:t>A scheduled Python job pulls from Case Center on a timer (systemd / cron).</a:t>
+            </a:r>
+            <a:endParaRPr lang="en-US" sz="1700" dirty="0"/>
+          </a:p>
+        </p:txBody>
+      </p:sp>
+      <p:sp>
+        <p:nvSpPr>
+          <p:cNvPr id="20" name="Shape 18"/>
+          <p:cNvSpPr/>
+          <p:nvPr/>
+        </p:nvSpPr>
+        <p:spPr>
+          <a:xfrm>
+            <a:off x="822960" y="5486400"/>
+            <a:ext cx="10561320" cy="713232"/>
+          </a:xfrm>
+          <a:prstGeom prst="roundRect">
+            <a:avLst>
+              <a:gd name="adj" fmla="val 7692"/>
+            </a:avLst>
+          </a:prstGeom>
+          <a:solidFill>
+            <a:srgbClr val="F7FAFC"/>
+          </a:solidFill>
+          <a:ln w="12700">
+            <a:solidFill>
+              <a:srgbClr val="E5E7EB"/>
+            </a:solidFill>
+            <a:prstDash val="solid"/>
+          </a:ln>
+        </p:spPr>
+      </p:sp>
+      <p:sp>
+        <p:nvSpPr>
+          <p:cNvPr id="21" name="Text 19"/>
+          <p:cNvSpPr/>
+          <p:nvPr/>
+        </p:nvSpPr>
+        <p:spPr>
+          <a:xfrm>
+            <a:off x="1051560" y="5486400"/>
+            <a:ext cx="10149840" cy="713232"/>
+          </a:xfrm>
+          <a:prstGeom prst="rect">
+            <a:avLst/>
+          </a:prstGeom>
+          <a:noFill/>
+          <a:ln/>
+        </p:spPr>
+        <p:txBody>
+          <a:bodyPr wrap="square" rtlCol="0" anchor="ctr"/>
+          <a:lstStyle/>
+          <a:p>
+            <a:pPr indent="0" marL="0">
+              <a:buNone/>
+            </a:pPr>
+            <a:r>
+              <a:rPr lang="en-US" sz="1250" b="1" dirty="0">
+                <a:solidFill>
+                  <a:srgbClr val="111827"/>
+                </a:solidFill>
+                <a:latin typeface="Segoe UI" pitchFamily="34" charset="0"/>
+                <a:ea typeface="Segoe UI" pitchFamily="34" charset="-122"/>
+                <a:cs typeface="Segoe UI" pitchFamily="34" charset="-120"/>
+              </a:rPr>
+              <a:t>🔒 Optional: </a:t>
+            </a:r>
+            <a:pPr indent="0" marL="0">
+              <a:buNone/>
+            </a:pPr>
+            <a:r>
+              <a:rPr lang="en-US" sz="1250" dirty="0">
+                <a:solidFill>
+                  <a:srgbClr val="111827"/>
+                </a:solidFill>
+                <a:latin typeface="Segoe UI" pitchFamily="34" charset="0"/>
+                <a:ea typeface="Segoe UI" pitchFamily="34" charset="-122"/>
+                <a:cs typeface="Segoe UI" pitchFamily="34" charset="-120"/>
+              </a:rPr>
+              <a:t>nginx + HTTPS in front.    </a:t>
+            </a:r>
+            <a:pPr indent="0" marL="0">
+              <a:buNone/>
+            </a:pPr>
+            <a:r>
+              <a:rPr lang="en-US" sz="1250" b="1" dirty="0">
+                <a:solidFill>
+                  <a:srgbClr val="111827"/>
+                </a:solidFill>
+                <a:latin typeface="Segoe UI" pitchFamily="34" charset="0"/>
+                <a:ea typeface="Segoe UI" pitchFamily="34" charset="-122"/>
+                <a:cs typeface="Segoe UI" pitchFamily="34" charset="-120"/>
+              </a:rPr>
+              <a:t>🧰 Node.js is build-time only </a:t>
+            </a:r>
+            <a:pPr indent="0" marL="0">
+              <a:buNone/>
+            </a:pPr>
+            <a:r>
+              <a:rPr lang="en-US" sz="1250" dirty="0">
+                <a:solidFill>
+                  <a:srgbClr val="111827"/>
+                </a:solidFill>
+                <a:latin typeface="Segoe UI" pitchFamily="34" charset="0"/>
+                <a:ea typeface="Segoe UI" pitchFamily="34" charset="-122"/>
+                <a:cs typeface="Segoe UI" pitchFamily="34" charset="-120"/>
+              </a:rPr>
+              <a:t>(bundler · tests · this deck) — the running site needs only Python + PostgreSQL.</a:t>
+            </a:r>
+            <a:endParaRPr lang="en-US" sz="1250" dirty="0"/>
+          </a:p>
+        </p:txBody>
+      </p:sp>
+    </p:spTree>
+  </p:cSld>
+  <p:clrMapOvr>
+    <a:masterClrMapping/>
+  </p:clrMapOvr>
+</p:sld>
+</file>
+
+<file path=ppt/slides/slide17.xml><?xml version="1.0" encoding="utf-8"?>
+<p:sld xmlns:a="http://schemas.openxmlformats.org/drawingml/2006/main" xmlns:r="http://schemas.openxmlformats.org/officeDocument/2006/relationships" xmlns:p="http://schemas.openxmlformats.org/presentationml/2006/main">
+  <p:cSld name="Slide 17">
+    <p:bg>
+      <p:bgPr>
+        <a:solidFill>
+          <a:srgbClr val="FFFFFF"/>
+        </a:solidFill>
+      </p:bgPr>
+    </p:bg>
+    <p:spTree>
+      <p:nvGrpSpPr>
+        <p:cNvPr id="1" name=""/>
+        <p:cNvGrpSpPr/>
+        <p:nvPr/>
+      </p:nvGrpSpPr>
+      <p:grpSpPr>
+        <a:xfrm>
+          <a:off x="0" y="0"/>
+          <a:ext cx="0" cy="0"/>
+          <a:chOff x="0" y="0"/>
+          <a:chExt cx="0" cy="0"/>
+        </a:xfrm>
+      </p:grpSpPr>
+      <p:sp>
+        <p:nvSpPr>
+          <p:cNvPr id="2" name="Shape 0"/>
+          <p:cNvSpPr/>
+          <p:nvPr/>
+        </p:nvSpPr>
+        <p:spPr>
+          <a:xfrm>
             <a:off x="0" y="0"/>
             <a:ext cx="12191695" cy="256032"/>
           </a:xfrm>

</xml_diff>